<commit_message>
feat(sylvia): 12 revisi dosen + modular frontmatter + zero-AI-markers + panduan sempro v3.0
- Eksekusi 12 butir revisi Sylvia: judul BAB 2 baris, rujukan bernomor,
  backslash 0, n.s. hapus, 3.5 jadi Tahap 1-5, Pearson -1..+1, Alpha 0.70,
  Generasi Z, diagram KS/VIF/Glejser + input-output
- Hapus varian NoBab3 (11 berkas + 2 skrip); 6 lembar formal eksisi ke
  modular; naskah utama Cover->TOC->Bab 1; PDF 47 hlm settled
- Rumusan masalah/tujuan bullet jadi nomor 1-6; bintang terpusat X1*/M*
  dipertahankan italic di DOCX selaras PDF
- Rule mandatory_no_ai_markers (M1-M9) + verify_no_ai_markers.py;
  settled-build C-LOT-3; WALLED-SERVER citation-links; TOC/LOT/LOF C-LOT-1
- Panduan belajar v3.0 (34 Q&A + bedah Bab 3 + naskah 7 slide); paket
  handoff Claude dikoreksi (6H, N 120-150, tanpa klaim paylater)
- Gate parity 7/7 PASS
</commit_message>
<xml_diff>
--- a/02_Persiapan_Sidang/ppt_seminar_proposal/Proposal_Arthur_Sempro_PokemonTCG.pptx
+++ b/02_Persiapan_Sidang/ppt_seminar_proposal/Proposal_Arthur_Sempro_PokemonTCG.pptx
@@ -2658,6 +2658,10 @@
             <a:prstDash val="solid"/>
           </a:ln>
         </p:spPr>
+        <p:txBody>
+          <a:bodyPr/>
+          <a:p/>
+        </p:txBody>
       </p:sp>
       <p:sp>
         <p:nvSpPr>
@@ -3266,6 +3270,10 @@
             <a:prstDash val="solid"/>
           </a:ln>
         </p:spPr>
+        <p:txBody>
+          <a:bodyPr/>
+          <a:p/>
+        </p:txBody>
       </p:sp>
       <p:sp>
         <p:nvSpPr>
@@ -3690,6 +3698,10 @@
             <a:prstDash val="solid"/>
           </a:ln>
         </p:spPr>
+        <p:txBody>
+          <a:bodyPr/>
+          <a:p/>
+        </p:txBody>
       </p:sp>
       <p:sp>
         <p:nvSpPr>
@@ -4172,6 +4184,10 @@
             <a:prstDash val="solid"/>
           </a:ln>
         </p:spPr>
+        <p:txBody>
+          <a:bodyPr/>
+          <a:p/>
+        </p:txBody>
       </p:sp>
       <p:sp>
         <p:nvSpPr>
@@ -5828,6 +5844,10 @@
             <a:prstDash val="solid"/>
           </a:ln>
         </p:spPr>
+        <p:txBody>
+          <a:bodyPr/>
+          <a:p/>
+        </p:txBody>
       </p:sp>
       <p:sp>
         <p:nvSpPr>
@@ -6597,6 +6617,10 @@
             <a:prstDash val="solid"/>
           </a:ln>
         </p:spPr>
+        <p:txBody>
+          <a:bodyPr/>
+          <a:p/>
+        </p:txBody>
       </p:sp>
       <p:sp>
         <p:nvSpPr>
@@ -6620,6 +6644,10 @@
             <a:prstDash val="solid"/>
           </a:ln>
         </p:spPr>
+        <p:txBody>
+          <a:bodyPr/>
+          <a:p/>
+        </p:txBody>
       </p:sp>
       <p:sp>
         <p:nvSpPr>
@@ -6643,6 +6671,10 @@
             <a:prstDash val="solid"/>
           </a:ln>
         </p:spPr>
+        <p:txBody>
+          <a:bodyPr/>
+          <a:p/>
+        </p:txBody>
       </p:sp>
       <p:sp>
         <p:nvSpPr>
@@ -6666,6 +6698,10 @@
             <a:prstDash val="solid"/>
           </a:ln>
         </p:spPr>
+        <p:txBody>
+          <a:bodyPr/>
+          <a:p/>
+        </p:txBody>
       </p:sp>
       <p:sp>
         <p:nvSpPr>
@@ -6780,6 +6816,10 @@
             <a:prstDash val="solid"/>
           </a:ln>
         </p:spPr>
+        <p:txBody>
+          <a:bodyPr/>
+          <a:p/>
+        </p:txBody>
       </p:sp>
       <p:sp>
         <p:nvSpPr>
@@ -6803,6 +6843,10 @@
             <a:prstDash val="solid"/>
           </a:ln>
         </p:spPr>
+        <p:txBody>
+          <a:bodyPr/>
+          <a:p/>
+        </p:txBody>
       </p:sp>
       <p:sp>
         <p:nvSpPr>
@@ -6826,6 +6870,10 @@
             <a:prstDash val="solid"/>
           </a:ln>
         </p:spPr>
+        <p:txBody>
+          <a:bodyPr/>
+          <a:p/>
+        </p:txBody>
       </p:sp>
       <p:sp>
         <p:nvSpPr>
@@ -6849,6 +6897,10 @@
             <a:prstDash val="solid"/>
           </a:ln>
         </p:spPr>
+        <p:txBody>
+          <a:bodyPr/>
+          <a:p/>
+        </p:txBody>
       </p:sp>
       <p:sp>
         <p:nvSpPr>
@@ -6963,6 +7015,10 @@
             <a:prstDash val="solid"/>
           </a:ln>
         </p:spPr>
+        <p:txBody>
+          <a:bodyPr/>
+          <a:p/>
+        </p:txBody>
       </p:sp>
       <p:sp>
         <p:nvSpPr>
@@ -6986,6 +7042,10 @@
             <a:prstDash val="solid"/>
           </a:ln>
         </p:spPr>
+        <p:txBody>
+          <a:bodyPr/>
+          <a:p/>
+        </p:txBody>
       </p:sp>
       <p:sp>
         <p:nvSpPr>
@@ -7009,6 +7069,10 @@
             <a:prstDash val="solid"/>
           </a:ln>
         </p:spPr>
+        <p:txBody>
+          <a:bodyPr/>
+          <a:p/>
+        </p:txBody>
       </p:sp>
       <p:sp>
         <p:nvSpPr>
@@ -7032,6 +7096,10 @@
             <a:prstDash val="solid"/>
           </a:ln>
         </p:spPr>
+        <p:txBody>
+          <a:bodyPr/>
+          <a:p/>
+        </p:txBody>
       </p:sp>
       <p:sp>
         <p:nvSpPr>
@@ -7351,6 +7419,10 @@
             <a:prstDash val="solid"/>
           </a:ln>
         </p:spPr>
+        <p:txBody>
+          <a:bodyPr/>
+          <a:p/>
+        </p:txBody>
       </p:sp>
       <p:sp>
         <p:nvSpPr>
@@ -7374,6 +7446,10 @@
             <a:prstDash val="solid"/>
           </a:ln>
         </p:spPr>
+        <p:txBody>
+          <a:bodyPr/>
+          <a:p/>
+        </p:txBody>
       </p:sp>
       <p:sp>
         <p:nvSpPr>
@@ -7397,6 +7473,10 @@
             <a:prstDash val="solid"/>
           </a:ln>
         </p:spPr>
+        <p:txBody>
+          <a:bodyPr/>
+          <a:p/>
+        </p:txBody>
       </p:sp>
       <p:sp>
         <p:nvSpPr>
@@ -7420,6 +7500,10 @@
             <a:prstDash val="solid"/>
           </a:ln>
         </p:spPr>
+        <p:txBody>
+          <a:bodyPr/>
+          <a:p/>
+        </p:txBody>
       </p:sp>
       <p:sp>
         <p:nvSpPr>
@@ -7613,6 +7697,10 @@
             <a:prstDash val="solid"/>
           </a:ln>
         </p:spPr>
+        <p:txBody>
+          <a:bodyPr/>
+          <a:p/>
+        </p:txBody>
       </p:sp>
       <p:sp>
         <p:nvSpPr>
@@ -7636,6 +7724,10 @@
             <a:prstDash val="solid"/>
           </a:ln>
         </p:spPr>
+        <p:txBody>
+          <a:bodyPr/>
+          <a:p/>
+        </p:txBody>
       </p:sp>
       <p:sp>
         <p:nvSpPr>
@@ -7659,6 +7751,10 @@
             <a:prstDash val="solid"/>
           </a:ln>
         </p:spPr>
+        <p:txBody>
+          <a:bodyPr/>
+          <a:p/>
+        </p:txBody>
       </p:sp>
       <p:sp>
         <p:nvSpPr>
@@ -7682,6 +7778,10 @@
             <a:prstDash val="solid"/>
           </a:ln>
         </p:spPr>
+        <p:txBody>
+          <a:bodyPr/>
+          <a:p/>
+        </p:txBody>
       </p:sp>
       <p:sp>
         <p:nvSpPr>
@@ -7875,6 +7975,10 @@
             <a:prstDash val="solid"/>
           </a:ln>
         </p:spPr>
+        <p:txBody>
+          <a:bodyPr/>
+          <a:p/>
+        </p:txBody>
       </p:sp>
       <p:sp>
         <p:nvSpPr>
@@ -7898,6 +8002,10 @@
             <a:prstDash val="solid"/>
           </a:ln>
         </p:spPr>
+        <p:txBody>
+          <a:bodyPr/>
+          <a:p/>
+        </p:txBody>
       </p:sp>
       <p:sp>
         <p:nvSpPr>
@@ -7921,6 +8029,10 @@
             <a:prstDash val="solid"/>
           </a:ln>
         </p:spPr>
+        <p:txBody>
+          <a:bodyPr/>
+          <a:p/>
+        </p:txBody>
       </p:sp>
       <p:sp>
         <p:nvSpPr>
@@ -7944,6 +8056,10 @@
             <a:prstDash val="solid"/>
           </a:ln>
         </p:spPr>
+        <p:txBody>
+          <a:bodyPr/>
+          <a:p/>
+        </p:txBody>
       </p:sp>
       <p:sp>
         <p:nvSpPr>
@@ -8137,6 +8253,10 @@
             <a:prstDash val="solid"/>
           </a:ln>
         </p:spPr>
+        <p:txBody>
+          <a:bodyPr/>
+          <a:p/>
+        </p:txBody>
       </p:sp>
       <p:sp>
         <p:nvSpPr>
@@ -8160,6 +8280,10 @@
             <a:prstDash val="solid"/>
           </a:ln>
         </p:spPr>
+        <p:txBody>
+          <a:bodyPr/>
+          <a:p/>
+        </p:txBody>
       </p:sp>
       <p:sp>
         <p:nvSpPr>
@@ -8183,6 +8307,10 @@
             <a:prstDash val="solid"/>
           </a:ln>
         </p:spPr>
+        <p:txBody>
+          <a:bodyPr/>
+          <a:p/>
+        </p:txBody>
       </p:sp>
       <p:sp>
         <p:nvSpPr>
@@ -8206,6 +8334,10 @@
             <a:prstDash val="solid"/>
           </a:ln>
         </p:spPr>
+        <p:txBody>
+          <a:bodyPr/>
+          <a:p/>
+        </p:txBody>
       </p:sp>
       <p:sp>
         <p:nvSpPr>
@@ -8399,6 +8531,10 @@
             <a:prstDash val="solid"/>
           </a:ln>
         </p:spPr>
+        <p:txBody>
+          <a:bodyPr/>
+          <a:p/>
+        </p:txBody>
       </p:sp>
       <p:sp>
         <p:nvSpPr>
@@ -8422,6 +8558,10 @@
             <a:prstDash val="solid"/>
           </a:ln>
         </p:spPr>
+        <p:txBody>
+          <a:bodyPr/>
+          <a:p/>
+        </p:txBody>
       </p:sp>
       <p:sp>
         <p:nvSpPr>
@@ -8445,6 +8585,10 @@
             <a:prstDash val="solid"/>
           </a:ln>
         </p:spPr>
+        <p:txBody>
+          <a:bodyPr/>
+          <a:p/>
+        </p:txBody>
       </p:sp>
       <p:sp>
         <p:nvSpPr>
@@ -8468,6 +8612,10 @@
             <a:prstDash val="solid"/>
           </a:ln>
         </p:spPr>
+        <p:txBody>
+          <a:bodyPr/>
+          <a:p/>
+        </p:txBody>
       </p:sp>
       <p:sp>
         <p:nvSpPr>
@@ -8661,6 +8809,10 @@
             <a:prstDash val="solid"/>
           </a:ln>
         </p:spPr>
+        <p:txBody>
+          <a:bodyPr/>
+          <a:p/>
+        </p:txBody>
       </p:sp>
       <p:sp>
         <p:nvSpPr>
@@ -8684,6 +8836,10 @@
             <a:prstDash val="solid"/>
           </a:ln>
         </p:spPr>
+        <p:txBody>
+          <a:bodyPr/>
+          <a:p/>
+        </p:txBody>
       </p:sp>
       <p:sp>
         <p:nvSpPr>
@@ -8707,6 +8863,10 @@
             <a:prstDash val="solid"/>
           </a:ln>
         </p:spPr>
+        <p:txBody>
+          <a:bodyPr/>
+          <a:p/>
+        </p:txBody>
       </p:sp>
       <p:sp>
         <p:nvSpPr>
@@ -8730,6 +8890,10 @@
             <a:prstDash val="solid"/>
           </a:ln>
         </p:spPr>
+        <p:txBody>
+          <a:bodyPr/>
+          <a:p/>
+        </p:txBody>
       </p:sp>
       <p:sp>
         <p:nvSpPr>
@@ -8914,6 +9078,10 @@
             <a:prstDash val="solid"/>
           </a:ln>
         </p:spPr>
+        <p:txBody>
+          <a:bodyPr/>
+          <a:p/>
+        </p:txBody>
       </p:sp>
       <p:sp>
         <p:nvSpPr>
@@ -11499,6 +11667,10 @@
             <a:prstDash val="solid"/>
           </a:ln>
         </p:spPr>
+        <p:txBody>
+          <a:bodyPr/>
+          <a:p/>
+        </p:txBody>
       </p:sp>
       <p:sp>
         <p:nvSpPr>
@@ -11907,6 +12079,10 @@
             <a:prstDash val="solid"/>
           </a:ln>
         </p:spPr>
+        <p:txBody>
+          <a:bodyPr/>
+          <a:p/>
+        </p:txBody>
       </p:sp>
       <p:sp>
         <p:nvSpPr>
@@ -12294,6 +12470,10 @@
             <a:prstDash val="solid"/>
           </a:ln>
         </p:spPr>
+        <p:txBody>
+          <a:bodyPr/>
+          <a:p/>
+        </p:txBody>
       </p:sp>
       <p:sp>
         <p:nvSpPr>
@@ -12317,6 +12497,10 @@
             <a:prstDash val="solid"/>
           </a:ln>
         </p:spPr>
+        <p:txBody>
+          <a:bodyPr/>
+          <a:p/>
+        </p:txBody>
       </p:sp>
       <p:sp>
         <p:nvSpPr>
@@ -12340,6 +12524,10 @@
             <a:prstDash val="solid"/>
           </a:ln>
         </p:spPr>
+        <p:txBody>
+          <a:bodyPr/>
+          <a:p/>
+        </p:txBody>
       </p:sp>
       <p:sp>
         <p:nvSpPr>
@@ -12363,6 +12551,10 @@
             <a:prstDash val="solid"/>
           </a:ln>
         </p:spPr>
+        <p:txBody>
+          <a:bodyPr/>
+          <a:p/>
+        </p:txBody>
       </p:sp>
       <p:sp>
         <p:nvSpPr>
@@ -12470,6 +12662,10 @@
             <a:prstDash val="solid"/>
           </a:ln>
         </p:spPr>
+        <p:txBody>
+          <a:bodyPr/>
+          <a:p/>
+        </p:txBody>
       </p:sp>
       <p:sp>
         <p:nvSpPr>
@@ -13051,6 +13247,10 @@
             <a:prstDash val="dash"/>
           </a:ln>
         </p:spPr>
+        <p:txBody>
+          <a:bodyPr/>
+          <a:p/>
+        </p:txBody>
       </p:sp>
       <p:sp>
         <p:nvSpPr>
@@ -13319,6 +13519,10 @@
             <a:prstDash val="dash"/>
           </a:ln>
         </p:spPr>
+        <p:txBody>
+          <a:bodyPr/>
+          <a:p/>
+        </p:txBody>
       </p:sp>
       <p:sp>
         <p:nvSpPr>
@@ -13587,6 +13791,10 @@
             <a:prstDash val="dash"/>
           </a:ln>
         </p:spPr>
+        <p:txBody>
+          <a:bodyPr/>
+          <a:p/>
+        </p:txBody>
       </p:sp>
       <p:sp>
         <p:nvSpPr>
@@ -13681,6 +13889,10 @@
             <a:prstDash val="solid"/>
           </a:ln>
         </p:spPr>
+        <p:txBody>
+          <a:bodyPr/>
+          <a:p/>
+        </p:txBody>
       </p:sp>
       <p:sp>
         <p:nvSpPr>
@@ -14573,7 +14785,7 @@
                 <a:ea typeface="Plus Jakarta Sans" pitchFamily="34" charset="-122"/>
                 <a:cs typeface="Plus Jakarta Sans" pitchFamily="34" charset="-120"/>
               </a:rPr>
-              <a:t>Lonjakan volume cetak global dalam 5 tahun terakhir (28,8 Miliar di FY2019 $\rightarrow$ 64,8 Miliar lembar di FY2024).</a:t>
+              <a:t>Lonjakan volume cetak global dalam 5 tahun terakhir (28,8 Miliar di FY2019 → 64,8 Miliar lembar di FY2024).</a:t>
             </a:r>
             <a:endParaRPr lang="en-US" sz="900" dirty="0"/>
           </a:p>
@@ -17494,6 +17706,10 @@
             <a:prstDash val="solid"/>
           </a:ln>
         </p:spPr>
+        <p:txBody>
+          <a:bodyPr/>
+          <a:p/>
+        </p:txBody>
       </p:sp>
       <p:sp>
         <p:nvSpPr>
@@ -17804,6 +18020,10 @@
             <a:prstDash val="solid"/>
           </a:ln>
         </p:spPr>
+        <p:txBody>
+          <a:bodyPr/>
+          <a:p/>
+        </p:txBody>
       </p:sp>
       <p:sp>
         <p:nvSpPr>
@@ -18288,6 +18508,10 @@
             <a:prstDash val="solid"/>
           </a:ln>
         </p:spPr>
+        <p:txBody>
+          <a:bodyPr/>
+          <a:p/>
+        </p:txBody>
       </p:sp>
       <p:sp>
         <p:nvSpPr>
@@ -18766,6 +18990,10 @@
             <a:prstDash val="solid"/>
           </a:ln>
         </p:spPr>
+        <p:txBody>
+          <a:bodyPr/>
+          <a:p/>
+        </p:txBody>
       </p:sp>
       <p:sp>
         <p:nvSpPr>
@@ -19062,6 +19290,10 @@
             <a:prstDash val="solid"/>
           </a:ln>
         </p:spPr>
+        <p:txBody>
+          <a:bodyPr/>
+          <a:p/>
+        </p:txBody>
       </p:sp>
       <p:sp>
         <p:nvSpPr>
@@ -19085,6 +19317,10 @@
             <a:prstDash val="solid"/>
           </a:ln>
         </p:spPr>
+        <p:txBody>
+          <a:bodyPr/>
+          <a:p/>
+        </p:txBody>
       </p:sp>
       <p:sp>
         <p:nvSpPr>
@@ -19108,6 +19344,10 @@
             <a:prstDash val="solid"/>
           </a:ln>
         </p:spPr>
+        <p:txBody>
+          <a:bodyPr/>
+          <a:p/>
+        </p:txBody>
       </p:sp>
       <p:sp>
         <p:nvSpPr>
@@ -19131,6 +19371,10 @@
             <a:prstDash val="solid"/>
           </a:ln>
         </p:spPr>
+        <p:txBody>
+          <a:bodyPr/>
+          <a:p/>
+        </p:txBody>
       </p:sp>
       <p:sp>
         <p:nvSpPr>
@@ -19383,6 +19627,10 @@
             <a:prstDash val="solid"/>
           </a:ln>
         </p:spPr>
+        <p:txBody>
+          <a:bodyPr/>
+          <a:p/>
+        </p:txBody>
       </p:sp>
       <p:sp>
         <p:nvSpPr>
@@ -19406,6 +19654,10 @@
             <a:prstDash val="solid"/>
           </a:ln>
         </p:spPr>
+        <p:txBody>
+          <a:bodyPr/>
+          <a:p/>
+        </p:txBody>
       </p:sp>
       <p:sp>
         <p:nvSpPr>
@@ -19429,6 +19681,10 @@
             <a:prstDash val="solid"/>
           </a:ln>
         </p:spPr>
+        <p:txBody>
+          <a:bodyPr/>
+          <a:p/>
+        </p:txBody>
       </p:sp>
       <p:sp>
         <p:nvSpPr>
@@ -19452,6 +19708,10 @@
             <a:prstDash val="solid"/>
           </a:ln>
         </p:spPr>
+        <p:txBody>
+          <a:bodyPr/>
+          <a:p/>
+        </p:txBody>
       </p:sp>
       <p:sp>
         <p:nvSpPr>
@@ -19633,6 +19893,10 @@
             <a:prstDash val="solid"/>
           </a:ln>
         </p:spPr>
+        <p:txBody>
+          <a:bodyPr/>
+          <a:p/>
+        </p:txBody>
       </p:sp>
       <p:sp>
         <p:nvSpPr>
@@ -19656,6 +19920,10 @@
             <a:prstDash val="solid"/>
           </a:ln>
         </p:spPr>
+        <p:txBody>
+          <a:bodyPr/>
+          <a:p/>
+        </p:txBody>
       </p:sp>
       <p:sp>
         <p:nvSpPr>
@@ -19679,6 +19947,10 @@
             <a:prstDash val="solid"/>
           </a:ln>
         </p:spPr>
+        <p:txBody>
+          <a:bodyPr/>
+          <a:p/>
+        </p:txBody>
       </p:sp>
       <p:sp>
         <p:nvSpPr>
@@ -19702,6 +19974,10 @@
             <a:prstDash val="solid"/>
           </a:ln>
         </p:spPr>
+        <p:txBody>
+          <a:bodyPr/>
+          <a:p/>
+        </p:txBody>
       </p:sp>
       <p:sp>
         <p:nvSpPr>
@@ -19883,6 +20159,10 @@
             <a:prstDash val="solid"/>
           </a:ln>
         </p:spPr>
+        <p:txBody>
+          <a:bodyPr/>
+          <a:p/>
+        </p:txBody>
       </p:sp>
       <p:sp>
         <p:nvSpPr>
@@ -19906,6 +20186,10 @@
             <a:prstDash val="solid"/>
           </a:ln>
         </p:spPr>
+        <p:txBody>
+          <a:bodyPr/>
+          <a:p/>
+        </p:txBody>
       </p:sp>
       <p:sp>
         <p:nvSpPr>
@@ -19929,6 +20213,10 @@
             <a:prstDash val="solid"/>
           </a:ln>
         </p:spPr>
+        <p:txBody>
+          <a:bodyPr/>
+          <a:p/>
+        </p:txBody>
       </p:sp>
       <p:sp>
         <p:nvSpPr>
@@ -19952,6 +20240,10 @@
             <a:prstDash val="solid"/>
           </a:ln>
         </p:spPr>
+        <p:txBody>
+          <a:bodyPr/>
+          <a:p/>
+        </p:txBody>
       </p:sp>
       <p:sp>
         <p:nvSpPr>
@@ -20884,6 +21176,10 @@
             <a:prstDash val="solid"/>
           </a:ln>
         </p:spPr>
+        <p:txBody>
+          <a:bodyPr/>
+          <a:p/>
+        </p:txBody>
       </p:sp>
       <p:sp>
         <p:nvSpPr>
@@ -20907,6 +21203,10 @@
             <a:prstDash val="solid"/>
           </a:ln>
         </p:spPr>
+        <p:txBody>
+          <a:bodyPr/>
+          <a:p/>
+        </p:txBody>
       </p:sp>
       <p:sp>
         <p:nvSpPr>
@@ -20930,6 +21230,10 @@
             <a:prstDash val="solid"/>
           </a:ln>
         </p:spPr>
+        <p:txBody>
+          <a:bodyPr/>
+          <a:p/>
+        </p:txBody>
       </p:sp>
       <p:sp>
         <p:nvSpPr>
@@ -20953,6 +21257,10 @@
             <a:prstDash val="solid"/>
           </a:ln>
         </p:spPr>
+        <p:txBody>
+          <a:bodyPr/>
+          <a:p/>
+        </p:txBody>
       </p:sp>
       <p:sp>
         <p:nvSpPr>
@@ -21099,6 +21407,10 @@
             <a:prstDash val="dash"/>
           </a:ln>
         </p:spPr>
+        <p:txBody>
+          <a:bodyPr/>
+          <a:p/>
+        </p:txBody>
       </p:sp>
       <p:sp>
         <p:nvSpPr>
@@ -21676,6 +21988,10 @@
             <a:prstDash val="solid"/>
           </a:ln>
         </p:spPr>
+        <p:txBody>
+          <a:bodyPr/>
+          <a:p/>
+        </p:txBody>
       </p:sp>
       <p:sp>
         <p:nvSpPr>
@@ -21699,6 +22015,10 @@
             <a:prstDash val="solid"/>
           </a:ln>
         </p:spPr>
+        <p:txBody>
+          <a:bodyPr/>
+          <a:p/>
+        </p:txBody>
       </p:sp>
       <p:sp>
         <p:nvSpPr>
@@ -21722,6 +22042,10 @@
             <a:prstDash val="solid"/>
           </a:ln>
         </p:spPr>
+        <p:txBody>
+          <a:bodyPr/>
+          <a:p/>
+        </p:txBody>
       </p:sp>
       <p:sp>
         <p:nvSpPr>
@@ -21745,6 +22069,10 @@
             <a:prstDash val="solid"/>
           </a:ln>
         </p:spPr>
+        <p:txBody>
+          <a:bodyPr/>
+          <a:p/>
+        </p:txBody>
       </p:sp>
       <p:sp>
         <p:nvSpPr>
@@ -21897,6 +22225,10 @@
             <a:prstDash val="dash"/>
           </a:ln>
         </p:spPr>
+        <p:txBody>
+          <a:bodyPr/>
+          <a:p/>
+        </p:txBody>
       </p:sp>
       <p:sp>
         <p:nvSpPr>
@@ -22000,6 +22332,10 @@
             <a:prstDash val="solid"/>
           </a:ln>
         </p:spPr>
+        <p:txBody>
+          <a:bodyPr/>
+          <a:p/>
+        </p:txBody>
       </p:sp>
       <p:sp>
         <p:nvSpPr>
@@ -22023,6 +22359,10 @@
             <a:prstDash val="solid"/>
           </a:ln>
         </p:spPr>
+        <p:txBody>
+          <a:bodyPr/>
+          <a:p/>
+        </p:txBody>
       </p:sp>
       <p:sp>
         <p:nvSpPr>
@@ -22046,6 +22386,10 @@
             <a:prstDash val="solid"/>
           </a:ln>
         </p:spPr>
+        <p:txBody>
+          <a:bodyPr/>
+          <a:p/>
+        </p:txBody>
       </p:sp>
       <p:sp>
         <p:nvSpPr>
@@ -22069,6 +22413,10 @@
             <a:prstDash val="solid"/>
           </a:ln>
         </p:spPr>
+        <p:txBody>
+          <a:bodyPr/>
+          <a:p/>
+        </p:txBody>
       </p:sp>
       <p:sp>
         <p:nvSpPr>
@@ -22221,6 +22569,10 @@
             <a:prstDash val="dash"/>
           </a:ln>
         </p:spPr>
+        <p:txBody>
+          <a:bodyPr/>
+          <a:p/>
+        </p:txBody>
       </p:sp>
       <p:sp>
         <p:nvSpPr>
@@ -22324,6 +22676,10 @@
             <a:prstDash val="solid"/>
           </a:ln>
         </p:spPr>
+        <p:txBody>
+          <a:bodyPr/>
+          <a:p/>
+        </p:txBody>
       </p:sp>
       <p:sp>
         <p:nvSpPr>
@@ -22347,6 +22703,10 @@
             <a:prstDash val="solid"/>
           </a:ln>
         </p:spPr>
+        <p:txBody>
+          <a:bodyPr/>
+          <a:p/>
+        </p:txBody>
       </p:sp>
       <p:sp>
         <p:nvSpPr>
@@ -22370,6 +22730,10 @@
             <a:prstDash val="solid"/>
           </a:ln>
         </p:spPr>
+        <p:txBody>
+          <a:bodyPr/>
+          <a:p/>
+        </p:txBody>
       </p:sp>
       <p:sp>
         <p:nvSpPr>
@@ -22393,6 +22757,10 @@
             <a:prstDash val="solid"/>
           </a:ln>
         </p:spPr>
+        <p:txBody>
+          <a:bodyPr/>
+          <a:p/>
+        </p:txBody>
       </p:sp>
       <p:sp>
         <p:nvSpPr>
@@ -22545,6 +22913,10 @@
             <a:prstDash val="dash"/>
           </a:ln>
         </p:spPr>
+        <p:txBody>
+          <a:bodyPr/>
+          <a:p/>
+        </p:txBody>
       </p:sp>
       <p:sp>
         <p:nvSpPr>

</xml_diff>